<commit_message>
docs/brief: the closing slide says what the chip is in plain words
Co-Authored-By: Claude Fable 5.1 <noreply@anthropic.com>
Claude-Session: https://claude.ai/code/session_01DkQpVYNjMdJtfzj74tR8ZC
</commit_message>
<xml_diff>
--- a/docs/brief/chip-that-says-no-brief.pptx
+++ b/docs/brief/chip-that-says-no-brief.pptx
@@ -124,60 +124,60 @@
   <p:extLst>
     <p:ext uri="{521415D9-36F7-43E2-AB2F-B90AF26B5E84}">
       <p14:sectionLst xmlns:p14="http://schemas.microsoft.com/office/powerpoint/2010/main">
-        <p14:section name="Opening" id="{28c84042-9b32-001a-057d-e92262b92a99}">
+        <p14:section name="Opening" id="{7318b034-3fa5-a806-0141-77ecf3e64a25}">
           <p14:sldIdLst>
             <p14:sldId id="256"/>
             <p14:sldId id="257"/>
           </p14:sldIdLst>
         </p14:section>
-        <p14:section name="Thesis" id="{ccb50fdd-306f-c37b-8773-2a3a64098e67}">
+        <p14:section name="Thesis" id="{b5d2f243-4500-fa1d-3e61-2602f958097c}">
           <p14:sldIdLst>
             <p14:sldId id="258"/>
             <p14:sldId id="259"/>
           </p14:sldIdLst>
         </p14:section>
-        <p14:section name="Logic" id="{5e74886f-59d0-5cc8-2270-861adbd84e2f}">
+        <p14:section name="Logic" id="{0301d9bd-3605-f3a1-4073-806f28ea7672}">
           <p14:sldIdLst>
             <p14:sldId id="260"/>
             <p14:sldId id="261"/>
           </p14:sldIdLst>
         </p14:section>
-        <p14:section name="Proposal" id="{21747d6b-33b7-3005-7508-bae3b306730c}">
+        <p14:section name="Proposal" id="{a02a8c10-1db2-f372-a429-0a7869b32210}">
           <p14:sldIdLst>
             <p14:sldId id="262"/>
             <p14:sldId id="263"/>
           </p14:sldIdLst>
         </p14:section>
-        <p14:section name="Layers" id="{7ed40503-aab5-8e8e-a6f2-cad685b88e39}">
+        <p14:section name="Layers" id="{f7a2759b-813b-cef4-f321-b12e0608b2d5}">
           <p14:sldIdLst>
             <p14:sldId id="264"/>
             <p14:sldId id="265"/>
           </p14:sldIdLst>
         </p14:section>
-        <p14:section name="How it meets the model" id="{c1db5bfa-1fc8-719b-f14a-1f98b21e8343}">
+        <p14:section name="How it meets the model" id="{7996bb09-4cc5-77c0-4770-a95d31d53da6}">
           <p14:sldIdLst>
             <p14:sldId id="266"/>
             <p14:sldId id="267"/>
           </p14:sldIdLst>
         </p14:section>
-        <p14:section name="Status" id="{4298726c-f861-c79c-b81a-bb5333b58955}">
+        <p14:section name="Status" id="{ff697b67-bb1e-c805-0c89-f6b035aecbbd}">
           <p14:sldIdLst>
             <p14:sldId id="268"/>
           </p14:sldIdLst>
         </p14:section>
-        <p14:section name="Challenges" id="{42c1667c-d0f4-f3d9-de63-408eee26e139}">
+        <p14:section name="Challenges" id="{08beeb9e-0df2-688e-3fe5-6fcb8a0973f1}">
           <p14:sldIdLst>
             <p14:sldId id="269"/>
             <p14:sldId id="270"/>
           </p14:sldIdLst>
         </p14:section>
-        <p14:section name="What I need" id="{f9b6ca15-1749-8ab4-2a03-1090367cb8c7}">
+        <p14:section name="What I need" id="{8748a8d7-55a1-48c6-7636-e55ad829b297}">
           <p14:sldIdLst>
             <p14:sldId id="271"/>
             <p14:sldId id="272"/>
           </p14:sldIdLst>
         </p14:section>
-        <p14:section name="Close" id="{99abe07a-1256-1f05-f51e-9f7a35ca6d23}">
+        <p14:section name="Close" id="{dc7570d7-6082-ab39-4ada-f064f33fe552}">
           <p14:sldIdLst>
             <p14:sldId id="273"/>
           </p14:sldIdLst>
@@ -1378,7 +1378,7 @@
           <a:p>
             <a:r>
               <a:rPr lang="en-US" dirty="0"/>
-              <a:t>Close on the sentence from docs/17, then questions. The repositories hold the model, the tests, the RTL, the circuit simulation and the audit; the blog series is the plain-English route in.</a:t>
+              <a:t>Close on the plain sentence: what it is, what it does, what it can stop. Then the two lines under it. The repositories hold the model, the tests, the RTL, the circuit simulation and the audit; the blog series is the plain-English route in.</a:t>
             </a:r>
             <a:endParaRPr lang="en-US" dirty="0"/>
           </a:p>
@@ -2563,26 +2563,26 @@
         </p:nvSpPr>
         <p:spPr>
           <a:xfrm>
-            <a:off x="548640" y="3200400"/>
-            <a:ext cx="7315200" cy="1645920"/>
-          </a:xfrm>
-          <a:prstGeom prst="rect">
-            <a:avLst/>
-          </a:prstGeom>
-          <a:noFill/>
-          <a:ln/>
-        </p:spPr>
-        <p:txBody>
-          <a:bodyPr wrap="square" lIns="0" tIns="0" rIns="0" bIns="0" rtlCol="0" anchor="t">
-            <a:normAutofit/>
-          </a:bodyPr>
-          <a:lstStyle/>
-          <a:p>
-            <a:pPr indent="0" marL="0">
-              <a:buNone/>
-            </a:pPr>
-            <a:r>
-              <a:rPr lang="en-US" sz="2000" dirty="0">
+            <a:off x="548640" y="3154680"/>
+            <a:ext cx="7680960" cy="1554480"/>
+          </a:xfrm>
+          <a:prstGeom prst="rect">
+            <a:avLst/>
+          </a:prstGeom>
+          <a:noFill/>
+          <a:ln/>
+        </p:spPr>
+        <p:txBody>
+          <a:bodyPr wrap="square" lIns="0" tIns="0" rIns="0" bIns="0" rtlCol="0" anchor="t">
+            <a:normAutofit/>
+          </a:bodyPr>
+          <a:lstStyle/>
+          <a:p>
+            <a:pPr indent="0" marL="0">
+              <a:buNone/>
+            </a:pPr>
+            <a:r>
+              <a:rPr lang="en-US" sz="1900" dirty="0">
                 <a:solidFill>
                   <a:schemeClr val="accent6"/>
                 </a:solidFill>
@@ -2592,7 +2592,7 @@
               </a:rPr>
               <a:t>A multi-layer hardware approach to AI safety. Each topic in two slides: the plain version with a picture, then the technical one.</a:t>
             </a:r>
-            <a:endParaRPr lang="en-US" sz="2000" dirty="0"/>
+            <a:endParaRPr lang="en-US" sz="1900" dirty="0"/>
           </a:p>
         </p:txBody>
       </p:sp>
@@ -15114,7 +15114,7 @@
                 <a:ea typeface="Georgia" pitchFamily="34" charset="-122"/>
                 <a:cs typeface="Georgia" pitchFamily="34" charset="-120"/>
               </a:rPr>
-              <a:t>The one-sentence version</a:t>
+              <a:t>In one sentence</a:t>
             </a:r>
             <a:endParaRPr lang="en-US" sz="4400" dirty="0"/>
           </a:p>
@@ -15128,26 +15128,26 @@
         </p:nvSpPr>
         <p:spPr>
           <a:xfrm>
-            <a:off x="548640" y="3200400"/>
-            <a:ext cx="7315200" cy="1645920"/>
-          </a:xfrm>
-          <a:prstGeom prst="rect">
-            <a:avLst/>
-          </a:prstGeom>
-          <a:noFill/>
-          <a:ln/>
-        </p:spPr>
-        <p:txBody>
-          <a:bodyPr wrap="square" lIns="0" tIns="0" rIns="0" bIns="0" rtlCol="0" anchor="t">
-            <a:normAutofit/>
-          </a:bodyPr>
-          <a:lstStyle/>
-          <a:p>
-            <a:pPr indent="0" marL="0">
-              <a:buNone/>
-            </a:pPr>
-            <a:r>
-              <a:rPr lang="en-US" sz="2000" dirty="0">
+            <a:off x="548640" y="3154680"/>
+            <a:ext cx="7680960" cy="1554480"/>
+          </a:xfrm>
+          <a:prstGeom prst="rect">
+            <a:avLst/>
+          </a:prstGeom>
+          <a:noFill/>
+          <a:ln/>
+        </p:spPr>
+        <p:txBody>
+          <a:bodyPr wrap="square" lIns="0" tIns="0" rIns="0" bIns="0" rtlCol="0" anchor="t">
+            <a:normAutofit/>
+          </a:bodyPr>
+          <a:lstStyle/>
+          <a:p>
+            <a:pPr indent="0" marL="0">
+              <a:buNone/>
+            </a:pPr>
+            <a:r>
+              <a:rPr lang="en-US" sz="1900" dirty="0">
                 <a:solidFill>
                   <a:schemeClr val="accent6"/>
                 </a:solidFill>
@@ -15155,9 +15155,9 @@
                 <a:ea typeface="Arial" pitchFamily="34" charset="-122"/>
                 <a:cs typeface="Arial" pitchFamily="34" charset="-120"/>
               </a:rPr>
-              <a:t>The governor never knows what the model is thinking and does not need to, because thinking fires nothing. A ticket does, and the model cannot mint one.</a:t>
-            </a:r>
-            <a:endParaRPr lang="en-US" sz="2000" dirty="0"/>
+              <a:t>A separate safety chip beside every AI GPU that checks each action the AI attempts against rules signed by people the AI cannot influence, stamps the allowed ones so the devices that carry them out can verify the stamp themselves, and cuts the power when something is wrong.</a:t>
+            </a:r>
+            <a:endParaRPr lang="en-US" sz="1900" dirty="0"/>
           </a:p>
         </p:txBody>
       </p:sp>
@@ -15210,26 +15210,90 @@
         </p:nvSpPr>
         <p:spPr>
           <a:xfrm>
-            <a:off x="548640" y="5029200"/>
-            <a:ext cx="8229600" cy="914400"/>
-          </a:xfrm>
-          <a:prstGeom prst="rect">
-            <a:avLst/>
-          </a:prstGeom>
-          <a:noFill/>
-          <a:ln/>
-        </p:spPr>
-        <p:txBody>
-          <a:bodyPr wrap="square" lIns="0" tIns="0" rIns="0" bIns="0" rtlCol="0" anchor="t">
-            <a:normAutofit/>
-          </a:bodyPr>
-          <a:lstStyle/>
-          <a:p>
-            <a:pPr indent="0" marL="0">
-              <a:buNone/>
-            </a:pPr>
-            <a:r>
-              <a:rPr lang="en-US" sz="1300" dirty="0">
+            <a:off x="548640" y="4800600"/>
+            <a:ext cx="7680960" cy="822960"/>
+          </a:xfrm>
+          <a:prstGeom prst="rect">
+            <a:avLst/>
+          </a:prstGeom>
+          <a:noFill/>
+          <a:ln/>
+        </p:spPr>
+        <p:txBody>
+          <a:bodyPr wrap="square" lIns="0" tIns="0" rIns="0" bIns="0" rtlCol="0" anchor="t">
+            <a:normAutofit/>
+          </a:bodyPr>
+          <a:lstStyle/>
+          <a:p>
+            <a:pPr indent="0" marL="0">
+              <a:spcAft>
+                <a:spcPts val="400"/>
+              </a:spcAft>
+              <a:buNone/>
+            </a:pPr>
+            <a:r>
+              <a:rPr lang="en-US" sz="1400" i="1" dirty="0">
+                <a:solidFill>
+                  <a:schemeClr val="accent1"/>
+                </a:solidFill>
+                <a:latin typeface="Arial" pitchFamily="34" charset="0"/>
+                <a:ea typeface="Arial" pitchFamily="34" charset="-122"/>
+                <a:cs typeface="Arial" pitchFamily="34" charset="-120"/>
+              </a:rPr>
+              <a:t>The AI can think whatever it likes. It cannot act without the stamp, and it cannot forge one.</a:t>
+            </a:r>
+            <a:endParaRPr lang="en-US" sz="1400" dirty="0"/>
+          </a:p>
+          <a:p>
+            <a:pPr indent="0" marL="0">
+              <a:spcAft>
+                <a:spcPts val="400"/>
+              </a:spcAft>
+              <a:buNone/>
+            </a:pPr>
+            <a:r>
+              <a:rPr lang="en-US" sz="1400" i="1" dirty="0">
+                <a:solidFill>
+                  <a:schemeClr val="accent1"/>
+                </a:solidFill>
+                <a:latin typeface="Arial" pitchFamily="34" charset="0"/>
+                <a:ea typeface="Arial" pitchFamily="34" charset="-122"/>
+                <a:cs typeface="Arial" pitchFamily="34" charset="-120"/>
+              </a:rPr>
+              <a:t>Added to the server's own boards. Nothing changes in the GPU or in CUDA.</a:t>
+            </a:r>
+            <a:endParaRPr lang="en-US" sz="1400" dirty="0"/>
+          </a:p>
+        </p:txBody>
+      </p:sp>
+      <p:sp>
+        <p:nvSpPr>
+          <p:cNvPr id="6" name="Text 4"/>
+          <p:cNvSpPr txBox="1"/>
+          <p:nvPr/>
+        </p:nvSpPr>
+        <p:spPr>
+          <a:xfrm>
+            <a:off x="548640" y="5623560"/>
+            <a:ext cx="8686800" cy="548640"/>
+          </a:xfrm>
+          <a:prstGeom prst="rect">
+            <a:avLst/>
+          </a:prstGeom>
+          <a:noFill/>
+          <a:ln/>
+        </p:spPr>
+        <p:txBody>
+          <a:bodyPr wrap="square" lIns="0" tIns="0" rIns="0" bIns="0" rtlCol="0" anchor="t">
+            <a:normAutofit/>
+          </a:bodyPr>
+          <a:lstStyle/>
+          <a:p>
+            <a:pPr indent="0" marL="0">
+              <a:buNone/>
+            </a:pPr>
+            <a:r>
+              <a:rPr lang="en-US" sz="1100" dirty="0">
                 <a:solidFill>
                   <a:schemeClr val="accent6"/>
                 </a:solidFill>
@@ -15237,33 +15301,16 @@
                 <a:ea typeface="Arial" pitchFamily="34" charset="-122"/>
                 <a:cs typeface="Arial" pitchFamily="34" charset="-120"/>
               </a:rPr>
-              <a:t>github.com/YobieBenjamin/safety-governor</a:t>
-            </a:r>
-            <a:endParaRPr lang="en-US" sz="1300" dirty="0"/>
-          </a:p>
-          <a:p>
-            <a:pPr indent="0" marL="0">
-              <a:buNone/>
-            </a:pPr>
-            <a:r>
-              <a:rPr lang="en-US" sz="1300" dirty="0">
-                <a:solidFill>
-                  <a:schemeClr val="accent6"/>
-                </a:solidFill>
-                <a:latin typeface="Arial" pitchFamily="34" charset="0"/>
-                <a:ea typeface="Arial" pitchFamily="34" charset="-122"/>
-                <a:cs typeface="Arial" pitchFamily="34" charset="-120"/>
-              </a:rPr>
-              <a:t>github.com/YobieBenjamin/hardware-and-silicon</a:t>
-            </a:r>
-            <a:endParaRPr lang="en-US" sz="1300" dirty="0"/>
-          </a:p>
-          <a:p>
-            <a:pPr indent="0" marL="0">
-              <a:buNone/>
-            </a:pPr>
-            <a:r>
-              <a:rPr lang="en-US" sz="1300" dirty="0">
+              <a:t>github.com/YobieBenjamin/safety-governor   ·   github.com/YobieBenjamin/hardware-and-silicon</a:t>
+            </a:r>
+            <a:endParaRPr lang="en-US" sz="1100" dirty="0"/>
+          </a:p>
+          <a:p>
+            <a:pPr indent="0" marL="0">
+              <a:buNone/>
+            </a:pPr>
+            <a:r>
+              <a:rPr lang="en-US" sz="1100" dirty="0">
                 <a:solidFill>
                   <a:schemeClr val="accent3"/>
                 </a:solidFill>
@@ -15273,7 +15320,7 @@
               </a:rPr>
               <a:t>The Chip That Says No, parts 1 to 4, and design documents 00 to 18</a:t>
             </a:r>
-            <a:endParaRPr lang="en-US" sz="1300" dirty="0"/>
+            <a:endParaRPr lang="en-US" sz="1100" dirty="0"/>
           </a:p>
         </p:txBody>
       </p:sp>

</xml_diff>